<commit_message>
Fixes from instructor notes.
</commit_message>
<xml_diff>
--- a/instructor/l07/l07-pad.pptx
+++ b/instructor/l07/l07-pad.pptx
@@ -250,7 +250,7 @@
           <a:p>
             <a:fld id="{1649E7D5-8023-1A4E-BE5A-A80A3E7BEC50}" type="datetimeFigureOut">
               <a:rPr lang="en-US" smtClean="0"/>
-              <a:t>9/27/23</a:t>
+              <a:t>9/30/26</a:t>
             </a:fld>
             <a:endParaRPr lang="en-US"/>
           </a:p>
@@ -420,7 +420,7 @@
           <a:p>
             <a:fld id="{1649E7D5-8023-1A4E-BE5A-A80A3E7BEC50}" type="datetimeFigureOut">
               <a:rPr lang="en-US" smtClean="0"/>
-              <a:t>9/27/23</a:t>
+              <a:t>9/30/26</a:t>
             </a:fld>
             <a:endParaRPr lang="en-US"/>
           </a:p>
@@ -600,7 +600,7 @@
           <a:p>
             <a:fld id="{1649E7D5-8023-1A4E-BE5A-A80A3E7BEC50}" type="datetimeFigureOut">
               <a:rPr lang="en-US" smtClean="0"/>
-              <a:t>9/27/23</a:t>
+              <a:t>9/30/26</a:t>
             </a:fld>
             <a:endParaRPr lang="en-US"/>
           </a:p>
@@ -770,7 +770,7 @@
           <a:p>
             <a:fld id="{1649E7D5-8023-1A4E-BE5A-A80A3E7BEC50}" type="datetimeFigureOut">
               <a:rPr lang="en-US" smtClean="0"/>
-              <a:t>9/27/23</a:t>
+              <a:t>9/30/26</a:t>
             </a:fld>
             <a:endParaRPr lang="en-US"/>
           </a:p>
@@ -1014,7 +1014,7 @@
           <a:p>
             <a:fld id="{1649E7D5-8023-1A4E-BE5A-A80A3E7BEC50}" type="datetimeFigureOut">
               <a:rPr lang="en-US" smtClean="0"/>
-              <a:t>9/27/23</a:t>
+              <a:t>9/30/26</a:t>
             </a:fld>
             <a:endParaRPr lang="en-US"/>
           </a:p>
@@ -1246,7 +1246,7 @@
           <a:p>
             <a:fld id="{1649E7D5-8023-1A4E-BE5A-A80A3E7BEC50}" type="datetimeFigureOut">
               <a:rPr lang="en-US" smtClean="0"/>
-              <a:t>9/27/23</a:t>
+              <a:t>9/30/26</a:t>
             </a:fld>
             <a:endParaRPr lang="en-US"/>
           </a:p>
@@ -1613,7 +1613,7 @@
           <a:p>
             <a:fld id="{1649E7D5-8023-1A4E-BE5A-A80A3E7BEC50}" type="datetimeFigureOut">
               <a:rPr lang="en-US" smtClean="0"/>
-              <a:t>9/27/23</a:t>
+              <a:t>9/30/26</a:t>
             </a:fld>
             <a:endParaRPr lang="en-US"/>
           </a:p>
@@ -1731,7 +1731,7 @@
           <a:p>
             <a:fld id="{1649E7D5-8023-1A4E-BE5A-A80A3E7BEC50}" type="datetimeFigureOut">
               <a:rPr lang="en-US" smtClean="0"/>
-              <a:t>9/27/23</a:t>
+              <a:t>9/30/26</a:t>
             </a:fld>
             <a:endParaRPr lang="en-US"/>
           </a:p>
@@ -1826,7 +1826,7 @@
           <a:p>
             <a:fld id="{1649E7D5-8023-1A4E-BE5A-A80A3E7BEC50}" type="datetimeFigureOut">
               <a:rPr lang="en-US" smtClean="0"/>
-              <a:t>9/27/23</a:t>
+              <a:t>9/30/26</a:t>
             </a:fld>
             <a:endParaRPr lang="en-US"/>
           </a:p>
@@ -2103,7 +2103,7 @@
           <a:p>
             <a:fld id="{1649E7D5-8023-1A4E-BE5A-A80A3E7BEC50}" type="datetimeFigureOut">
               <a:rPr lang="en-US" smtClean="0"/>
-              <a:t>9/27/23</a:t>
+              <a:t>9/30/26</a:t>
             </a:fld>
             <a:endParaRPr lang="en-US"/>
           </a:p>
@@ -2360,7 +2360,7 @@
           <a:p>
             <a:fld id="{1649E7D5-8023-1A4E-BE5A-A80A3E7BEC50}" type="datetimeFigureOut">
               <a:rPr lang="en-US" smtClean="0"/>
-              <a:t>9/27/23</a:t>
+              <a:t>9/30/26</a:t>
             </a:fld>
             <a:endParaRPr lang="en-US"/>
           </a:p>
@@ -2573,7 +2573,7 @@
           <a:p>
             <a:fld id="{1649E7D5-8023-1A4E-BE5A-A80A3E7BEC50}" type="datetimeFigureOut">
               <a:rPr lang="en-US" smtClean="0"/>
-              <a:t>9/27/23</a:t>
+              <a:t>9/30/26</a:t>
             </a:fld>
             <a:endParaRPr lang="en-US"/>
           </a:p>
@@ -3378,7 +3378,7 @@
         <p:spPr>
           <a:xfrm>
             <a:off x="632177" y="2260136"/>
-            <a:ext cx="2308578" cy="2308324"/>
+            <a:ext cx="2308578" cy="2031325"/>
           </a:xfrm>
           <a:prstGeom prst="rect">
             <a:avLst/>
@@ -3428,12 +3428,6 @@
             <a:r>
               <a:rPr lang="en-US" dirty="0"/>
               <a:t>background</a:t>
-            </a:r>
-          </a:p>
-          <a:p>
-            <a:r>
-              <a:rPr lang="en-US" dirty="0"/>
-              <a:t>egg image</a:t>
             </a:r>
           </a:p>
         </p:txBody>
@@ -3525,7 +3519,7 @@
         <p:spPr>
           <a:xfrm>
             <a:off x="6067777" y="2260136"/>
-            <a:ext cx="2308578" cy="1477328"/>
+            <a:ext cx="2308578" cy="1754326"/>
           </a:xfrm>
           <a:prstGeom prst="rect">
             <a:avLst/>
@@ -3563,6 +3557,12 @@
             <a:r>
               <a:rPr lang="en-US" dirty="0"/>
               <a:t>on-mouse</a:t>
+            </a:r>
+          </a:p>
+          <a:p>
+            <a:r>
+              <a:rPr lang="en-US" dirty="0"/>
+              <a:t>on-key</a:t>
             </a:r>
           </a:p>
         </p:txBody>

</xml_diff>